<commit_message>
Rebrand the manual and decks as BrokerVerse OOTB and add the 11 architecture documents
- User manual (183 pages) and the 9 persona decks rebuilt in place: iorta TechNXT branding, no BIBS/BDOI text,
  screenshots recaptured, new sign-in security, user maintenance and report chapters
- docs/architecture: 11 separate documents (docx + pdf) with diagrams, sources and build tools
- Go-live checklist: correct purge command, liveness/readiness checks, database time zone
- E2E report summary brought up to date
</commit_message>
<xml_diff>
--- a/docs/decks/BrokerVerse_Agent_Referrer_Guide.pptx
+++ b/docs/decks/BrokerVerse_Agent_Referrer_Guide.pptx
@@ -3272,7 +3272,7 @@
                 </a:solidFill>
                 <a:latin typeface="Calibri"/>
               </a:rPr>
-              <a:t>BDO Insure (BDOI) insurance broking · Philippines · PHP</a:t>
+              <a:t>BrokerVerse OOTB · insurance broking · Philippines · PHP</a:t>
             </a:r>
           </a:p>
         </p:txBody>
@@ -3819,7 +3819,7 @@
                 </a:solidFill>
                 <a:latin typeface="Calibri"/>
               </a:rPr>
-              <a:t>Operations &gt; Home</a:t>
+              <a:t>Agent Dashboard (Operations &gt; Home)</a:t>
             </a:r>
           </a:p>
         </p:txBody>
@@ -9482,7 +9482,7 @@
                 </a:solidFill>
                 <a:latin typeface="Calibri"/>
               </a:rPr>
-              <a:t>Contact number accepts the 10-digit form (9171234567); 09… and +63… forms are not yet accepted.</a:t>
+              <a:t>Your session is kept in the browser’s local storage: sign out on shared computers and keep the browser up to date.</a:t>
             </a:r>
           </a:p>
           <a:p>
@@ -9503,7 +9503,7 @@
                 </a:solidFill>
                 <a:latin typeface="Calibri"/>
               </a:rPr>
-              <a:t>An existing lead has no “Create Quote” action yet: create the quote right after saving the lead.</a:t>
+              <a:t>Two-factor set-up shows a setup key and an app link, but no QR code: type the key into the authenticator app.</a:t>
             </a:r>
           </a:p>
           <a:p>
@@ -9524,7 +9524,7 @@
                 </a:solidFill>
                 <a:latin typeface="Calibri"/>
               </a:rPr>
-              <a:t>Some quote lists (policy types, vehicle details, signatories) are fixed lists until linked to the masters.</a:t>
+              <a:t>Screens are in English or Thai; Filipino is configured but has no translation yet.</a:t>
             </a:r>
           </a:p>
           <a:p>
@@ -9545,70 +9545,7 @@
                 </a:solidFill>
                 <a:latin typeface="Calibri"/>
               </a:rPr>
-              <a:t>CTPL treatment (separate policy or part of the premium) is awaiting a business decision.</a:t>
-            </a:r>
-          </a:p>
-          <a:p>
-            <a:pPr marL="201168" indent="-182880">
-              <a:spcAft>
-                <a:spcPts val="800"/>
-              </a:spcAft>
-              <a:buClr>
-                <a:srgbClr val="5B6778"/>
-              </a:buClr>
-              <a:buFont typeface="Arial"/>
-              <a:buChar char="•"/>
-            </a:pPr>
-            <a:r>
-              <a:rPr sz="1500">
-                <a:solidFill>
-                  <a:srgbClr val="1F2937"/>
-                </a:solidFill>
-                <a:latin typeface="Calibri"/>
-              </a:rPr>
-              <a:t>ID card, ID number and vehicle identifiers are not yet mandatory at conversion: check them before Next.</a:t>
-            </a:r>
-          </a:p>
-          <a:p>
-            <a:pPr marL="201168" indent="-182880">
-              <a:spcAft>
-                <a:spcPts val="800"/>
-              </a:spcAft>
-              <a:buClr>
-                <a:srgbClr val="5B6778"/>
-              </a:buClr>
-              <a:buFont typeface="Arial"/>
-              <a:buChar char="•"/>
-            </a:pPr>
-            <a:r>
-              <a:rPr sz="1500">
-                <a:solidFill>
-                  <a:srgbClr val="1F2937"/>
-                </a:solidFill>
-                <a:latin typeface="Calibri"/>
-              </a:rPr>
-              <a:t>The payment step at conversion is a simulated confirmation; real receipting is done by Finance.</a:t>
-            </a:r>
-          </a:p>
-          <a:p>
-            <a:pPr marL="201168" indent="-182880">
-              <a:spcAft>
-                <a:spcPts val="800"/>
-              </a:spcAft>
-              <a:buClr>
-                <a:srgbClr val="5B6778"/>
-              </a:buClr>
-              <a:buFont typeface="Arial"/>
-              <a:buChar char="•"/>
-            </a:pPr>
-            <a:r>
-              <a:rPr sz="1500">
-                <a:solidFill>
-                  <a:srgbClr val="1F2937"/>
-                </a:solidFill>
-                <a:latin typeface="Calibri"/>
-              </a:rPr>
-              <a:t>Commission accrues to the user who created the policy: create your own quotes.</a:t>
+              <a:t>The commission goes to the referrer chosen on the quote (Account Code, Commission &amp; Referral): choose yourself.</a:t>
             </a:r>
           </a:p>
         </p:txBody>
@@ -9729,7 +9666,7 @@
                 </a:solidFill>
                 <a:latin typeface="Calibri"/>
               </a:rPr>
-              <a:t>Save the lead, then create the quote immediately.</a:t>
+              <a:t>Open the lead and select Create Quote.</a:t>
             </a:r>
           </a:p>
           <a:p>
@@ -10078,7 +10015,7 @@
                 </a:solidFill>
                 <a:latin typeface="Calibri"/>
               </a:rPr>
-              <a:t>&lt;to be confirmed by BDOI&gt;</a:t>
+              <a:t>&lt;service desk to be confirmed&gt;</a:t>
             </a:r>
           </a:p>
         </p:txBody>
@@ -10727,7 +10664,7 @@
                 </a:solidFill>
                 <a:latin typeface="Calibri"/>
               </a:rPr>
-              <a:t>raises endorsements and claim notices, follows renewals.</a:t>
+              <a:t>raises endorsements and claim notices, renews own expiring policies.</a:t>
             </a:r>
           </a:p>
           <a:p>
@@ -10871,7 +10808,7 @@
                 </a:solidFill>
                 <a:latin typeface="Calibri"/>
               </a:rPr>
-              <a:t>User name ramon.agent. Lands on Operations &gt; Home; the Agent Dashboard shows your leads, clients, policies sold and commission.</a:t>
+              <a:t>User name ramon.agent. Lands on the Agent Dashboard: your leads, clients, policies sold, commission and premium collected on your book.</a:t>
             </a:r>
           </a:p>
         </p:txBody>
@@ -11358,7 +11295,7 @@
                 </a:solidFill>
                 <a:latin typeface="Calibri"/>
               </a:rPr>
-              <a:t>Menus and screens granted to this role (menuPermissions); anything else is hidden and blocked by the route guard and the API.</a:t>
+              <a:t>Menus granted to the agent role; the renewals workspace (queue, batch, at-risk, negotiations, lapse, performance) is run by Sales and Underwriting.</a:t>
             </a:r>
           </a:p>
         </p:txBody>
@@ -11372,7 +11309,7 @@
         <p:spPr>
           <a:xfrm>
             <a:off x="457200" y="1645920"/>
-            <a:ext cx="3636264" cy="3202178"/>
+            <a:ext cx="3636264" cy="2969768"/>
           </a:xfrm>
           <a:prstGeom prst="roundRect">
             <a:avLst>
@@ -11499,7 +11436,7 @@
         <p:spPr>
           <a:xfrm>
             <a:off x="566928" y="2121408"/>
-            <a:ext cx="3435095" cy="2653538"/>
+            <a:ext cx="3435095" cy="2421128"/>
           </a:xfrm>
           <a:prstGeom prst="rect">
             <a:avLst/>
@@ -11541,7 +11478,7 @@
         <p:spPr>
           <a:xfrm>
             <a:off x="4276344" y="1645920"/>
-            <a:ext cx="3636264" cy="3202178"/>
+            <a:ext cx="3636264" cy="2969768"/>
           </a:xfrm>
           <a:prstGeom prst="roundRect">
             <a:avLst>
@@ -11668,7 +11605,7 @@
         <p:spPr>
           <a:xfrm>
             <a:off x="4386072" y="2121408"/>
-            <a:ext cx="3435095" cy="2653538"/>
+            <a:ext cx="3435095" cy="2421128"/>
           </a:xfrm>
           <a:prstGeom prst="rect">
             <a:avLst/>
@@ -11822,7 +11759,7 @@
                 </a:solidFill>
                 <a:latin typeface="Calibri"/>
               </a:rPr>
-              <a:t>Renewals: Renewal Policy, Batch, Queue, Retention Analytics, At-Risk, Negotiations, Lapse Mgmt, Performance</a:t>
+              <a:t>Renewals &gt; Renewal Policy (renew your own expiring policies)</a:t>
             </a:r>
           </a:p>
         </p:txBody>
@@ -11836,7 +11773,7 @@
         <p:spPr>
           <a:xfrm>
             <a:off x="8095488" y="1645920"/>
-            <a:ext cx="3636264" cy="3202178"/>
+            <a:ext cx="3636264" cy="2969768"/>
           </a:xfrm>
           <a:prstGeom prst="roundRect">
             <a:avLst>
@@ -11963,7 +11900,7 @@
         <p:spPr>
           <a:xfrm>
             <a:off x="8205215" y="2121408"/>
-            <a:ext cx="3435095" cy="2653538"/>
+            <a:ext cx="3435095" cy="2421128"/>
           </a:xfrm>
           <a:prstGeom prst="rect">
             <a:avLst/>
@@ -12487,7 +12424,7 @@
                 </a:solidFill>
                 <a:latin typeface="Calibri"/>
               </a:rPr>
-              <a:t>earned commission (3,990.71 net after WHT), collected premium, receivables, gross premium.</a:t>
+              <a:t>earned commission, collected premium, receivables and gross premium from the bills of your book.</a:t>
             </a:r>
           </a:p>
           <a:p>
@@ -13043,7 +12980,7 @@
                 </a:solidFill>
                 <a:latin typeface="Calibri"/>
               </a:rPr>
-              <a:t>required fields, e-mail format, 10-digit mobile, date of birth.</a:t>
+              <a:t>required fields, e-mail format, mobile 0917 123 4567 or +63 917 123 4567, date of birth.</a:t>
             </a:r>
           </a:p>
           <a:p>
@@ -13073,7 +13010,7 @@
                 </a:solidFill>
                 <a:latin typeface="Calibri"/>
               </a:rPr>
-              <a:t>View, Edit, Delete (draft only), Bulk Upload.</a:t>
+              <a:t>View, Edit, Delete, Bulk Upload.</a:t>
             </a:r>
           </a:p>
           <a:p>
@@ -13103,7 +13040,7 @@
                 </a:solidFill>
                 <a:latin typeface="Calibri"/>
               </a:rPr>
-              <a:t>go straight to Create Quote after saving.</a:t>
+              <a:t>Create Quote from Lead Details.</a:t>
             </a:r>
           </a:p>
         </p:txBody>
@@ -13336,24 +13273,22 @@
       </p:sp>
       <p:sp>
         <p:nvSpPr>
-          <p:cNvPr id="8" name="Rounded Rectangle 7"/>
+          <p:cNvPr id="8" name="Rectangle 7"/>
           <p:cNvSpPr/>
           <p:nvPr/>
         </p:nvSpPr>
         <p:spPr>
           <a:xfrm>
-            <a:off x="457200" y="1280160"/>
-            <a:ext cx="7269480" cy="4526280"/>
-          </a:xfrm>
-          <a:prstGeom prst="roundRect">
-            <a:avLst>
-              <a:gd name="adj" fmla="val 4000"/>
-            </a:avLst>
+            <a:off x="420624" y="1243584"/>
+            <a:ext cx="5066683" cy="4599432"/>
+          </a:xfrm>
+          <a:prstGeom prst="rect">
+            <a:avLst/>
           </a:prstGeom>
           <a:solidFill>
             <a:srgbClr val="FFFFFF"/>
           </a:solidFill>
-          <a:ln w="9525">
+          <a:ln w="12700">
             <a:solidFill>
               <a:srgbClr val="D5DEEA"/>
             </a:solidFill>
@@ -13382,922 +13317,38 @@
           </a:p>
         </p:txBody>
       </p:sp>
-      <p:sp>
-        <p:nvSpPr>
-          <p:cNvPr id="9" name="TextBox 8"/>
-          <p:cNvSpPr txBox="1"/>
-          <p:nvPr/>
-        </p:nvSpPr>
-        <p:spPr>
-          <a:xfrm>
-            <a:off x="777240" y="1463039"/>
-            <a:ext cx="6629400" cy="320040"/>
-          </a:xfrm>
-          <a:prstGeom prst="rect">
-            <a:avLst/>
-          </a:prstGeom>
-          <a:noFill/>
-        </p:spPr>
-        <p:txBody>
-          <a:bodyPr wrap="square" lIns="0" rIns="0" tIns="0" bIns="0" anchor="t"/>
-          <a:lstStyle/>
-          <a:p>
-            <a:pPr algn="l"/>
-            <a:r>
-              <a:rPr sz="1400" b="1" i="0">
-                <a:solidFill>
-                  <a:srgbClr val="0B4F9C"/>
-                </a:solidFill>
-                <a:latin typeface="Calibri"/>
-              </a:rPr>
-              <a:t>Step by step</a:t>
-            </a:r>
-          </a:p>
-        </p:txBody>
-      </p:sp>
-      <p:sp>
-        <p:nvSpPr>
-          <p:cNvPr id="10" name="Oval 9"/>
-          <p:cNvSpPr/>
-          <p:nvPr/>
-        </p:nvSpPr>
-        <p:spPr>
-          <a:xfrm>
-            <a:off x="868680" y="1965960"/>
-            <a:ext cx="384048" cy="384048"/>
-          </a:xfrm>
-          <a:prstGeom prst="ellipse">
-            <a:avLst/>
-          </a:prstGeom>
-          <a:solidFill>
-            <a:srgbClr val="1E88E5"/>
-          </a:solidFill>
-          <a:ln>
-            <a:noFill/>
+      <p:pic>
+        <p:nvPicPr>
+          <p:cNvPr id="9" name="Picture 8" descr="image.jpg"/>
+          <p:cNvPicPr>
+            <a:picLocks noChangeAspect="1"/>
+          </p:cNvPicPr>
+          <p:nvPr/>
+        </p:nvPicPr>
+        <p:blipFill>
+          <a:blip r:embed="rId3"/>
+          <a:stretch>
+            <a:fillRect/>
+          </a:stretch>
+        </p:blipFill>
+        <p:spPr>
+          <a:xfrm>
+            <a:off x="457200" y="1280160"/>
+            <a:ext cx="4993531" cy="4526280"/>
+          </a:xfrm>
+          <a:prstGeom prst="rect">
+            <a:avLst/>
+          </a:prstGeom>
+          <a:ln w="6350">
+            <a:solidFill>
+              <a:srgbClr val="D5DEEA"/>
+            </a:solidFill>
           </a:ln>
-          <a:effectLst/>
-        </p:spPr>
-        <p:style>
-          <a:lnRef idx="1">
-            <a:schemeClr val="accent1"/>
-          </a:lnRef>
-          <a:fillRef idx="3">
-            <a:schemeClr val="accent1"/>
-          </a:fillRef>
-          <a:effectRef idx="2">
-            <a:schemeClr val="accent1"/>
-          </a:effectRef>
-          <a:fontRef idx="minor">
-            <a:schemeClr val="lt1"/>
-          </a:fontRef>
-        </p:style>
-        <p:txBody>
-          <a:bodyPr rtlCol="0" anchor="ctr"/>
-          <a:lstStyle/>
-          <a:p>
-            <a:pPr algn="ctr"/>
-          </a:p>
-        </p:txBody>
-      </p:sp>
-      <p:sp>
-        <p:nvSpPr>
-          <p:cNvPr id="11" name="TextBox 10"/>
-          <p:cNvSpPr txBox="1"/>
-          <p:nvPr/>
-        </p:nvSpPr>
-        <p:spPr>
-          <a:xfrm>
-            <a:off x="868680" y="1965960"/>
-            <a:ext cx="384048" cy="384048"/>
-          </a:xfrm>
-          <a:prstGeom prst="rect">
-            <a:avLst/>
-          </a:prstGeom>
-          <a:noFill/>
-        </p:spPr>
-        <p:txBody>
-          <a:bodyPr wrap="square" lIns="0" rIns="0" tIns="0" bIns="0" anchor="ctr"/>
-          <a:lstStyle/>
-          <a:p>
-            <a:pPr algn="ctr"/>
-            <a:r>
-              <a:rPr sz="1300" b="1" i="0">
-                <a:solidFill>
-                  <a:srgbClr val="FFFFFF"/>
-                </a:solidFill>
-                <a:latin typeface="Calibri"/>
-              </a:rPr>
-              <a:t>1</a:t>
-            </a:r>
-          </a:p>
-        </p:txBody>
-      </p:sp>
-      <p:sp>
-        <p:nvSpPr>
-          <p:cNvPr id="12" name="Rectangle 11"/>
-          <p:cNvSpPr/>
-          <p:nvPr/>
-        </p:nvSpPr>
-        <p:spPr>
-          <a:xfrm>
-            <a:off x="1051560" y="2368296"/>
-            <a:ext cx="18288" cy="196595"/>
-          </a:xfrm>
-          <a:prstGeom prst="rect">
-            <a:avLst/>
-          </a:prstGeom>
-          <a:solidFill>
-            <a:srgbClr val="D5DEEA"/>
-          </a:solidFill>
-          <a:ln>
-            <a:noFill/>
-          </a:ln>
-          <a:effectLst/>
-        </p:spPr>
-        <p:style>
-          <a:lnRef idx="1">
-            <a:schemeClr val="accent1"/>
-          </a:lnRef>
-          <a:fillRef idx="3">
-            <a:schemeClr val="accent1"/>
-          </a:fillRef>
-          <a:effectRef idx="2">
-            <a:schemeClr val="accent1"/>
-          </a:effectRef>
-          <a:fontRef idx="minor">
-            <a:schemeClr val="lt1"/>
-          </a:fontRef>
-        </p:style>
-        <p:txBody>
-          <a:bodyPr rtlCol="0" anchor="ctr"/>
-          <a:lstStyle/>
-          <a:p>
-            <a:pPr algn="ctr"/>
-          </a:p>
-        </p:txBody>
-      </p:sp>
-      <p:sp>
-        <p:nvSpPr>
-          <p:cNvPr id="13" name="TextBox 12"/>
-          <p:cNvSpPr txBox="1"/>
-          <p:nvPr/>
-        </p:nvSpPr>
-        <p:spPr>
-          <a:xfrm>
-            <a:off x="1463040" y="1965960"/>
-            <a:ext cx="5897880" cy="384048"/>
-          </a:xfrm>
-          <a:prstGeom prst="rect">
-            <a:avLst/>
-          </a:prstGeom>
-          <a:noFill/>
-        </p:spPr>
-        <p:txBody>
-          <a:bodyPr wrap="square" lIns="0" rIns="0" tIns="0" bIns="0" anchor="ctr"/>
-          <a:lstStyle/>
-          <a:p>
-            <a:pPr algn="l"/>
-            <a:r>
-              <a:rPr sz="1500" b="0" i="0">
-                <a:solidFill>
-                  <a:srgbClr val="1F2937"/>
-                </a:solidFill>
-                <a:latin typeface="Calibri"/>
-              </a:rPr>
-              <a:t>Choose insurer and product</a:t>
-            </a:r>
-          </a:p>
-        </p:txBody>
-      </p:sp>
-      <p:sp>
-        <p:nvSpPr>
-          <p:cNvPr id="14" name="Oval 13"/>
-          <p:cNvSpPr/>
-          <p:nvPr/>
-        </p:nvSpPr>
-        <p:spPr>
-          <a:xfrm>
-            <a:off x="868680" y="2583179"/>
-            <a:ext cx="384048" cy="384048"/>
-          </a:xfrm>
-          <a:prstGeom prst="ellipse">
-            <a:avLst/>
-          </a:prstGeom>
-          <a:solidFill>
-            <a:srgbClr val="1E88E5"/>
-          </a:solidFill>
-          <a:ln>
-            <a:noFill/>
-          </a:ln>
-          <a:effectLst/>
-        </p:spPr>
-        <p:style>
-          <a:lnRef idx="1">
-            <a:schemeClr val="accent1"/>
-          </a:lnRef>
-          <a:fillRef idx="3">
-            <a:schemeClr val="accent1"/>
-          </a:fillRef>
-          <a:effectRef idx="2">
-            <a:schemeClr val="accent1"/>
-          </a:effectRef>
-          <a:fontRef idx="minor">
-            <a:schemeClr val="lt1"/>
-          </a:fontRef>
-        </p:style>
-        <p:txBody>
-          <a:bodyPr rtlCol="0" anchor="ctr"/>
-          <a:lstStyle/>
-          <a:p>
-            <a:pPr algn="ctr"/>
-          </a:p>
-        </p:txBody>
-      </p:sp>
-      <p:sp>
-        <p:nvSpPr>
-          <p:cNvPr id="15" name="TextBox 14"/>
-          <p:cNvSpPr txBox="1"/>
-          <p:nvPr/>
-        </p:nvSpPr>
-        <p:spPr>
-          <a:xfrm>
-            <a:off x="868680" y="2583179"/>
-            <a:ext cx="384048" cy="384048"/>
-          </a:xfrm>
-          <a:prstGeom prst="rect">
-            <a:avLst/>
-          </a:prstGeom>
-          <a:noFill/>
-        </p:spPr>
-        <p:txBody>
-          <a:bodyPr wrap="square" lIns="0" rIns="0" tIns="0" bIns="0" anchor="ctr"/>
-          <a:lstStyle/>
-          <a:p>
-            <a:pPr algn="ctr"/>
-            <a:r>
-              <a:rPr sz="1300" b="1" i="0">
-                <a:solidFill>
-                  <a:srgbClr val="FFFFFF"/>
-                </a:solidFill>
-                <a:latin typeface="Calibri"/>
-              </a:rPr>
-              <a:t>2</a:t>
-            </a:r>
-          </a:p>
-        </p:txBody>
-      </p:sp>
-      <p:sp>
-        <p:nvSpPr>
-          <p:cNvPr id="16" name="Rectangle 15"/>
-          <p:cNvSpPr/>
-          <p:nvPr/>
-        </p:nvSpPr>
-        <p:spPr>
-          <a:xfrm>
-            <a:off x="1051560" y="2985515"/>
-            <a:ext cx="18288" cy="196595"/>
-          </a:xfrm>
-          <a:prstGeom prst="rect">
-            <a:avLst/>
-          </a:prstGeom>
-          <a:solidFill>
-            <a:srgbClr val="D5DEEA"/>
-          </a:solidFill>
-          <a:ln>
-            <a:noFill/>
-          </a:ln>
-          <a:effectLst/>
-        </p:spPr>
-        <p:style>
-          <a:lnRef idx="1">
-            <a:schemeClr val="accent1"/>
-          </a:lnRef>
-          <a:fillRef idx="3">
-            <a:schemeClr val="accent1"/>
-          </a:fillRef>
-          <a:effectRef idx="2">
-            <a:schemeClr val="accent1"/>
-          </a:effectRef>
-          <a:fontRef idx="minor">
-            <a:schemeClr val="lt1"/>
-          </a:fontRef>
-        </p:style>
-        <p:txBody>
-          <a:bodyPr rtlCol="0" anchor="ctr"/>
-          <a:lstStyle/>
-          <a:p>
-            <a:pPr algn="ctr"/>
-          </a:p>
-        </p:txBody>
-      </p:sp>
-      <p:sp>
-        <p:nvSpPr>
-          <p:cNvPr id="17" name="TextBox 16"/>
-          <p:cNvSpPr txBox="1"/>
-          <p:nvPr/>
-        </p:nvSpPr>
-        <p:spPr>
-          <a:xfrm>
-            <a:off x="1463040" y="2583179"/>
-            <a:ext cx="5897880" cy="384048"/>
-          </a:xfrm>
-          <a:prstGeom prst="rect">
-            <a:avLst/>
-          </a:prstGeom>
-          <a:noFill/>
-        </p:spPr>
-        <p:txBody>
-          <a:bodyPr wrap="square" lIns="0" rIns="0" tIns="0" bIns="0" anchor="ctr"/>
-          <a:lstStyle/>
-          <a:p>
-            <a:pPr algn="l"/>
-            <a:r>
-              <a:rPr sz="1500" b="0" i="0">
-                <a:solidFill>
-                  <a:srgbClr val="1F2937"/>
-                </a:solidFill>
-                <a:latin typeface="Calibri"/>
-              </a:rPr>
-              <a:t>Vehicle and cover details</a:t>
-            </a:r>
-          </a:p>
-        </p:txBody>
-      </p:sp>
-      <p:sp>
-        <p:nvSpPr>
-          <p:cNvPr id="18" name="Oval 17"/>
-          <p:cNvSpPr/>
-          <p:nvPr/>
-        </p:nvSpPr>
-        <p:spPr>
-          <a:xfrm>
-            <a:off x="868680" y="3200400"/>
-            <a:ext cx="384048" cy="384048"/>
-          </a:xfrm>
-          <a:prstGeom prst="ellipse">
-            <a:avLst/>
-          </a:prstGeom>
-          <a:solidFill>
-            <a:srgbClr val="1E88E5"/>
-          </a:solidFill>
-          <a:ln>
-            <a:noFill/>
-          </a:ln>
-          <a:effectLst/>
-        </p:spPr>
-        <p:style>
-          <a:lnRef idx="1">
-            <a:schemeClr val="accent1"/>
-          </a:lnRef>
-          <a:fillRef idx="3">
-            <a:schemeClr val="accent1"/>
-          </a:fillRef>
-          <a:effectRef idx="2">
-            <a:schemeClr val="accent1"/>
-          </a:effectRef>
-          <a:fontRef idx="minor">
-            <a:schemeClr val="lt1"/>
-          </a:fontRef>
-        </p:style>
-        <p:txBody>
-          <a:bodyPr rtlCol="0" anchor="ctr"/>
-          <a:lstStyle/>
-          <a:p>
-            <a:pPr algn="ctr"/>
-          </a:p>
-        </p:txBody>
-      </p:sp>
-      <p:sp>
-        <p:nvSpPr>
-          <p:cNvPr id="19" name="TextBox 18"/>
-          <p:cNvSpPr txBox="1"/>
-          <p:nvPr/>
-        </p:nvSpPr>
-        <p:spPr>
-          <a:xfrm>
-            <a:off x="868680" y="3200400"/>
-            <a:ext cx="384048" cy="384048"/>
-          </a:xfrm>
-          <a:prstGeom prst="rect">
-            <a:avLst/>
-          </a:prstGeom>
-          <a:noFill/>
-        </p:spPr>
-        <p:txBody>
-          <a:bodyPr wrap="square" lIns="0" rIns="0" tIns="0" bIns="0" anchor="ctr"/>
-          <a:lstStyle/>
-          <a:p>
-            <a:pPr algn="ctr"/>
-            <a:r>
-              <a:rPr sz="1300" b="1" i="0">
-                <a:solidFill>
-                  <a:srgbClr val="FFFFFF"/>
-                </a:solidFill>
-                <a:latin typeface="Calibri"/>
-              </a:rPr>
-              <a:t>3</a:t>
-            </a:r>
-          </a:p>
-        </p:txBody>
-      </p:sp>
-      <p:sp>
-        <p:nvSpPr>
-          <p:cNvPr id="20" name="Rectangle 19"/>
-          <p:cNvSpPr/>
-          <p:nvPr/>
-        </p:nvSpPr>
-        <p:spPr>
-          <a:xfrm>
-            <a:off x="1051560" y="3602736"/>
-            <a:ext cx="18288" cy="196595"/>
-          </a:xfrm>
-          <a:prstGeom prst="rect">
-            <a:avLst/>
-          </a:prstGeom>
-          <a:solidFill>
-            <a:srgbClr val="D5DEEA"/>
-          </a:solidFill>
-          <a:ln>
-            <a:noFill/>
-          </a:ln>
-          <a:effectLst/>
-        </p:spPr>
-        <p:style>
-          <a:lnRef idx="1">
-            <a:schemeClr val="accent1"/>
-          </a:lnRef>
-          <a:fillRef idx="3">
-            <a:schemeClr val="accent1"/>
-          </a:fillRef>
-          <a:effectRef idx="2">
-            <a:schemeClr val="accent1"/>
-          </a:effectRef>
-          <a:fontRef idx="minor">
-            <a:schemeClr val="lt1"/>
-          </a:fontRef>
-        </p:style>
-        <p:txBody>
-          <a:bodyPr rtlCol="0" anchor="ctr"/>
-          <a:lstStyle/>
-          <a:p>
-            <a:pPr algn="ctr"/>
-          </a:p>
-        </p:txBody>
-      </p:sp>
-      <p:sp>
-        <p:nvSpPr>
-          <p:cNvPr id="21" name="TextBox 20"/>
-          <p:cNvSpPr txBox="1"/>
-          <p:nvPr/>
-        </p:nvSpPr>
-        <p:spPr>
-          <a:xfrm>
-            <a:off x="1463040" y="3200400"/>
-            <a:ext cx="5897880" cy="384048"/>
-          </a:xfrm>
-          <a:prstGeom prst="rect">
-            <a:avLst/>
-          </a:prstGeom>
-          <a:noFill/>
-        </p:spPr>
-        <p:txBody>
-          <a:bodyPr wrap="square" lIns="0" rIns="0" tIns="0" bIns="0" anchor="ctr"/>
-          <a:lstStyle/>
-          <a:p>
-            <a:pPr algn="l"/>
-            <a:r>
-              <a:rPr sz="1500" b="0" i="0">
-                <a:solidFill>
-                  <a:srgbClr val="1F2937"/>
-                </a:solidFill>
-                <a:latin typeface="Calibri"/>
-              </a:rPr>
-              <a:t>Plan recommendation</a:t>
-            </a:r>
-          </a:p>
-        </p:txBody>
-      </p:sp>
-      <p:sp>
-        <p:nvSpPr>
-          <p:cNvPr id="22" name="Oval 21"/>
-          <p:cNvSpPr/>
-          <p:nvPr/>
-        </p:nvSpPr>
-        <p:spPr>
-          <a:xfrm>
-            <a:off x="868680" y="3817620"/>
-            <a:ext cx="384048" cy="384048"/>
-          </a:xfrm>
-          <a:prstGeom prst="ellipse">
-            <a:avLst/>
-          </a:prstGeom>
-          <a:solidFill>
-            <a:srgbClr val="1E88E5"/>
-          </a:solidFill>
-          <a:ln>
-            <a:noFill/>
-          </a:ln>
-          <a:effectLst/>
-        </p:spPr>
-        <p:style>
-          <a:lnRef idx="1">
-            <a:schemeClr val="accent1"/>
-          </a:lnRef>
-          <a:fillRef idx="3">
-            <a:schemeClr val="accent1"/>
-          </a:fillRef>
-          <a:effectRef idx="2">
-            <a:schemeClr val="accent1"/>
-          </a:effectRef>
-          <a:fontRef idx="minor">
-            <a:schemeClr val="lt1"/>
-          </a:fontRef>
-        </p:style>
-        <p:txBody>
-          <a:bodyPr rtlCol="0" anchor="ctr"/>
-          <a:lstStyle/>
-          <a:p>
-            <a:pPr algn="ctr"/>
-          </a:p>
-        </p:txBody>
-      </p:sp>
-      <p:sp>
-        <p:nvSpPr>
-          <p:cNvPr id="23" name="TextBox 22"/>
-          <p:cNvSpPr txBox="1"/>
-          <p:nvPr/>
-        </p:nvSpPr>
-        <p:spPr>
-          <a:xfrm>
-            <a:off x="868680" y="3817620"/>
-            <a:ext cx="384048" cy="384048"/>
-          </a:xfrm>
-          <a:prstGeom prst="rect">
-            <a:avLst/>
-          </a:prstGeom>
-          <a:noFill/>
-        </p:spPr>
-        <p:txBody>
-          <a:bodyPr wrap="square" lIns="0" rIns="0" tIns="0" bIns="0" anchor="ctr"/>
-          <a:lstStyle/>
-          <a:p>
-            <a:pPr algn="ctr"/>
-            <a:r>
-              <a:rPr sz="1300" b="1" i="0">
-                <a:solidFill>
-                  <a:srgbClr val="FFFFFF"/>
-                </a:solidFill>
-                <a:latin typeface="Calibri"/>
-              </a:rPr>
-              <a:t>4</a:t>
-            </a:r>
-          </a:p>
-        </p:txBody>
-      </p:sp>
-      <p:sp>
-        <p:nvSpPr>
-          <p:cNvPr id="24" name="Rectangle 23"/>
-          <p:cNvSpPr/>
-          <p:nvPr/>
-        </p:nvSpPr>
-        <p:spPr>
-          <a:xfrm>
-            <a:off x="1051560" y="4219956"/>
-            <a:ext cx="18288" cy="196595"/>
-          </a:xfrm>
-          <a:prstGeom prst="rect">
-            <a:avLst/>
-          </a:prstGeom>
-          <a:solidFill>
-            <a:srgbClr val="D5DEEA"/>
-          </a:solidFill>
-          <a:ln>
-            <a:noFill/>
-          </a:ln>
-          <a:effectLst/>
-        </p:spPr>
-        <p:style>
-          <a:lnRef idx="1">
-            <a:schemeClr val="accent1"/>
-          </a:lnRef>
-          <a:fillRef idx="3">
-            <a:schemeClr val="accent1"/>
-          </a:fillRef>
-          <a:effectRef idx="2">
-            <a:schemeClr val="accent1"/>
-          </a:effectRef>
-          <a:fontRef idx="minor">
-            <a:schemeClr val="lt1"/>
-          </a:fontRef>
-        </p:style>
-        <p:txBody>
-          <a:bodyPr rtlCol="0" anchor="ctr"/>
-          <a:lstStyle/>
-          <a:p>
-            <a:pPr algn="ctr"/>
-          </a:p>
-        </p:txBody>
-      </p:sp>
-      <p:sp>
-        <p:nvSpPr>
-          <p:cNvPr id="25" name="TextBox 24"/>
-          <p:cNvSpPr txBox="1"/>
-          <p:nvPr/>
-        </p:nvSpPr>
-        <p:spPr>
-          <a:xfrm>
-            <a:off x="1463040" y="3817620"/>
-            <a:ext cx="5897880" cy="384048"/>
-          </a:xfrm>
-          <a:prstGeom prst="rect">
-            <a:avLst/>
-          </a:prstGeom>
-          <a:noFill/>
-        </p:spPr>
-        <p:txBody>
-          <a:bodyPr wrap="square" lIns="0" rIns="0" tIns="0" bIns="0" anchor="ctr"/>
-          <a:lstStyle/>
-          <a:p>
-            <a:pPr algn="l"/>
-            <a:r>
-              <a:rPr sz="1500" b="0" i="0">
-                <a:solidFill>
-                  <a:srgbClr val="1F2937"/>
-                </a:solidFill>
-                <a:latin typeface="Calibri"/>
-              </a:rPr>
-              <a:t>Coverage and add-ons</a:t>
-            </a:r>
-          </a:p>
-        </p:txBody>
-      </p:sp>
-      <p:sp>
-        <p:nvSpPr>
-          <p:cNvPr id="26" name="Oval 25"/>
-          <p:cNvSpPr/>
-          <p:nvPr/>
-        </p:nvSpPr>
-        <p:spPr>
-          <a:xfrm>
-            <a:off x="868680" y="4434840"/>
-            <a:ext cx="384048" cy="384048"/>
-          </a:xfrm>
-          <a:prstGeom prst="ellipse">
-            <a:avLst/>
-          </a:prstGeom>
-          <a:solidFill>
-            <a:srgbClr val="1E88E5"/>
-          </a:solidFill>
-          <a:ln>
-            <a:noFill/>
-          </a:ln>
-          <a:effectLst/>
-        </p:spPr>
-        <p:style>
-          <a:lnRef idx="1">
-            <a:schemeClr val="accent1"/>
-          </a:lnRef>
-          <a:fillRef idx="3">
-            <a:schemeClr val="accent1"/>
-          </a:fillRef>
-          <a:effectRef idx="2">
-            <a:schemeClr val="accent1"/>
-          </a:effectRef>
-          <a:fontRef idx="minor">
-            <a:schemeClr val="lt1"/>
-          </a:fontRef>
-        </p:style>
-        <p:txBody>
-          <a:bodyPr rtlCol="0" anchor="ctr"/>
-          <a:lstStyle/>
-          <a:p>
-            <a:pPr algn="ctr"/>
-          </a:p>
-        </p:txBody>
-      </p:sp>
-      <p:sp>
-        <p:nvSpPr>
-          <p:cNvPr id="27" name="TextBox 26"/>
-          <p:cNvSpPr txBox="1"/>
-          <p:nvPr/>
-        </p:nvSpPr>
-        <p:spPr>
-          <a:xfrm>
-            <a:off x="868680" y="4434840"/>
-            <a:ext cx="384048" cy="384048"/>
-          </a:xfrm>
-          <a:prstGeom prst="rect">
-            <a:avLst/>
-          </a:prstGeom>
-          <a:noFill/>
-        </p:spPr>
-        <p:txBody>
-          <a:bodyPr wrap="square" lIns="0" rIns="0" tIns="0" bIns="0" anchor="ctr"/>
-          <a:lstStyle/>
-          <a:p>
-            <a:pPr algn="ctr"/>
-            <a:r>
-              <a:rPr sz="1300" b="1" i="0">
-                <a:solidFill>
-                  <a:srgbClr val="FFFFFF"/>
-                </a:solidFill>
-                <a:latin typeface="Calibri"/>
-              </a:rPr>
-              <a:t>5</a:t>
-            </a:r>
-          </a:p>
-        </p:txBody>
-      </p:sp>
-      <p:sp>
-        <p:nvSpPr>
-          <p:cNvPr id="28" name="Rectangle 27"/>
-          <p:cNvSpPr/>
-          <p:nvPr/>
-        </p:nvSpPr>
-        <p:spPr>
-          <a:xfrm>
-            <a:off x="1051560" y="4837176"/>
-            <a:ext cx="18288" cy="196595"/>
-          </a:xfrm>
-          <a:prstGeom prst="rect">
-            <a:avLst/>
-          </a:prstGeom>
-          <a:solidFill>
-            <a:srgbClr val="D5DEEA"/>
-          </a:solidFill>
-          <a:ln>
-            <a:noFill/>
-          </a:ln>
-          <a:effectLst/>
-        </p:spPr>
-        <p:style>
-          <a:lnRef idx="1">
-            <a:schemeClr val="accent1"/>
-          </a:lnRef>
-          <a:fillRef idx="3">
-            <a:schemeClr val="accent1"/>
-          </a:fillRef>
-          <a:effectRef idx="2">
-            <a:schemeClr val="accent1"/>
-          </a:effectRef>
-          <a:fontRef idx="minor">
-            <a:schemeClr val="lt1"/>
-          </a:fontRef>
-        </p:style>
-        <p:txBody>
-          <a:bodyPr rtlCol="0" anchor="ctr"/>
-          <a:lstStyle/>
-          <a:p>
-            <a:pPr algn="ctr"/>
-          </a:p>
-        </p:txBody>
-      </p:sp>
-      <p:sp>
-        <p:nvSpPr>
-          <p:cNvPr id="29" name="TextBox 28"/>
-          <p:cNvSpPr txBox="1"/>
-          <p:nvPr/>
-        </p:nvSpPr>
-        <p:spPr>
-          <a:xfrm>
-            <a:off x="1463040" y="4434840"/>
-            <a:ext cx="5897880" cy="384048"/>
-          </a:xfrm>
-          <a:prstGeom prst="rect">
-            <a:avLst/>
-          </a:prstGeom>
-          <a:noFill/>
-        </p:spPr>
-        <p:txBody>
-          <a:bodyPr wrap="square" lIns="0" rIns="0" tIns="0" bIns="0" anchor="ctr"/>
-          <a:lstStyle/>
-          <a:p>
-            <a:pPr algn="l"/>
-            <a:r>
-              <a:rPr sz="1500" b="0" i="0">
-                <a:solidFill>
-                  <a:srgbClr val="1F2937"/>
-                </a:solidFill>
-                <a:latin typeface="Calibri"/>
-              </a:rPr>
-              <a:t>Order summary: taxes, commission</a:t>
-            </a:r>
-          </a:p>
-        </p:txBody>
-      </p:sp>
-      <p:sp>
-        <p:nvSpPr>
-          <p:cNvPr id="30" name="Oval 29"/>
-          <p:cNvSpPr/>
-          <p:nvPr/>
-        </p:nvSpPr>
-        <p:spPr>
-          <a:xfrm>
-            <a:off x="868680" y="5052059"/>
-            <a:ext cx="384048" cy="384048"/>
-          </a:xfrm>
-          <a:prstGeom prst="ellipse">
-            <a:avLst/>
-          </a:prstGeom>
-          <a:solidFill>
-            <a:srgbClr val="43A047"/>
-          </a:solidFill>
-          <a:ln>
-            <a:noFill/>
-          </a:ln>
-          <a:effectLst/>
-        </p:spPr>
-        <p:style>
-          <a:lnRef idx="1">
-            <a:schemeClr val="accent1"/>
-          </a:lnRef>
-          <a:fillRef idx="3">
-            <a:schemeClr val="accent1"/>
-          </a:fillRef>
-          <a:effectRef idx="2">
-            <a:schemeClr val="accent1"/>
-          </a:effectRef>
-          <a:fontRef idx="minor">
-            <a:schemeClr val="lt1"/>
-          </a:fontRef>
-        </p:style>
-        <p:txBody>
-          <a:bodyPr rtlCol="0" anchor="ctr"/>
-          <a:lstStyle/>
-          <a:p>
-            <a:pPr algn="ctr"/>
-          </a:p>
-        </p:txBody>
-      </p:sp>
-      <p:sp>
-        <p:nvSpPr>
-          <p:cNvPr id="31" name="TextBox 30"/>
-          <p:cNvSpPr txBox="1"/>
-          <p:nvPr/>
-        </p:nvSpPr>
-        <p:spPr>
-          <a:xfrm>
-            <a:off x="868680" y="5052059"/>
-            <a:ext cx="384048" cy="384048"/>
-          </a:xfrm>
-          <a:prstGeom prst="rect">
-            <a:avLst/>
-          </a:prstGeom>
-          <a:noFill/>
-        </p:spPr>
-        <p:txBody>
-          <a:bodyPr wrap="square" lIns="0" rIns="0" tIns="0" bIns="0" anchor="ctr"/>
-          <a:lstStyle/>
-          <a:p>
-            <a:pPr algn="ctr"/>
-            <a:r>
-              <a:rPr sz="1300" b="1" i="0">
-                <a:solidFill>
-                  <a:srgbClr val="FFFFFF"/>
-                </a:solidFill>
-                <a:latin typeface="Calibri"/>
-              </a:rPr>
-              <a:t>6</a:t>
-            </a:r>
-          </a:p>
-        </p:txBody>
-      </p:sp>
-      <p:sp>
-        <p:nvSpPr>
-          <p:cNvPr id="32" name="TextBox 31"/>
-          <p:cNvSpPr txBox="1"/>
-          <p:nvPr/>
-        </p:nvSpPr>
-        <p:spPr>
-          <a:xfrm>
-            <a:off x="1463040" y="5052059"/>
-            <a:ext cx="5897880" cy="384048"/>
-          </a:xfrm>
-          <a:prstGeom prst="rect">
-            <a:avLst/>
-          </a:prstGeom>
-          <a:noFill/>
-        </p:spPr>
-        <p:txBody>
-          <a:bodyPr wrap="square" lIns="0" rIns="0" tIns="0" bIns="0" anchor="ctr"/>
-          <a:lstStyle/>
-          <a:p>
-            <a:pPr algn="l"/>
-            <a:r>
-              <a:rPr sz="1500" b="0" i="0">
-                <a:solidFill>
-                  <a:srgbClr val="1F2937"/>
-                </a:solidFill>
-                <a:latin typeface="Calibri"/>
-              </a:rPr>
-              <a:t>Send for approval</a:t>
-            </a:r>
-          </a:p>
-        </p:txBody>
-      </p:sp>
-      <p:sp>
-        <p:nvSpPr>
-          <p:cNvPr id="33" name="TextBox 32"/>
+        </p:spPr>
+      </p:pic>
+      <p:sp>
+        <p:nvSpPr>
+          <p:cNvPr id="10" name="TextBox 9"/>
           <p:cNvSpPr txBox="1"/>
           <p:nvPr/>
         </p:nvSpPr>
@@ -14323,14 +13374,14 @@
                 </a:solidFill>
                 <a:latin typeface="Calibri"/>
               </a:rPr>
-              <a:t>Quotation wizard steps (QT-2026-00001, MAPFRE, Toyota Rav4)</a:t>
-            </a:r>
-          </a:p>
-        </p:txBody>
-      </p:sp>
-      <p:sp>
-        <p:nvSpPr>
-          <p:cNvPr id="34" name="Rounded Rectangle 33"/>
+              <a:t>Live screen — Create Quote, step 3: coverage details after Calculate — signed in as ramon.agent</a:t>
+            </a:r>
+          </a:p>
+        </p:txBody>
+      </p:sp>
+      <p:sp>
+        <p:nvSpPr>
+          <p:cNvPr id="11" name="Rounded Rectangle 10"/>
           <p:cNvSpPr/>
           <p:nvPr/>
         </p:nvSpPr>
@@ -14378,7 +13429,7 @@
       </p:sp>
       <p:sp>
         <p:nvSpPr>
-          <p:cNvPr id="35" name="TextBox 34"/>
+          <p:cNvPr id="12" name="TextBox 11"/>
           <p:cNvSpPr txBox="1"/>
           <p:nvPr/>
         </p:nvSpPr>
@@ -14404,14 +13455,14 @@
                 </a:solidFill>
                 <a:latin typeface="Calibri"/>
               </a:rPr>
-              <a:t>Operations &gt; Quotation</a:t>
-            </a:r>
-          </a:p>
-        </p:txBody>
-      </p:sp>
-      <p:sp>
-        <p:nvSpPr>
-          <p:cNvPr id="36" name="TextBox 35"/>
+              <a:t>Lead Details &gt; Create Quote (5 steps)</a:t>
+            </a:r>
+          </a:p>
+        </p:txBody>
+      </p:sp>
+      <p:sp>
+        <p:nvSpPr>
+          <p:cNvPr id="13" name="TextBox 12"/>
           <p:cNvSpPr txBox="1"/>
           <p:nvPr/>
         </p:nvSpPr>
@@ -14778,24 +13829,22 @@
       </p:sp>
       <p:sp>
         <p:nvSpPr>
-          <p:cNvPr id="8" name="Rounded Rectangle 7"/>
+          <p:cNvPr id="8" name="Rectangle 7"/>
           <p:cNvSpPr/>
           <p:nvPr/>
         </p:nvSpPr>
         <p:spPr>
           <a:xfrm>
-            <a:off x="457200" y="1280160"/>
-            <a:ext cx="7269480" cy="4526280"/>
-          </a:xfrm>
-          <a:prstGeom prst="roundRect">
-            <a:avLst>
-              <a:gd name="adj" fmla="val 4000"/>
-            </a:avLst>
+            <a:off x="420624" y="1243584"/>
+            <a:ext cx="7315200" cy="4599432"/>
+          </a:xfrm>
+          <a:prstGeom prst="rect">
+            <a:avLst/>
           </a:prstGeom>
           <a:solidFill>
             <a:srgbClr val="FFFFFF"/>
           </a:solidFill>
-          <a:ln w="9525">
+          <a:ln w="12700">
             <a:solidFill>
               <a:srgbClr val="D5DEEA"/>
             </a:solidFill>
@@ -14824,922 +13873,38 @@
           </a:p>
         </p:txBody>
       </p:sp>
-      <p:sp>
-        <p:nvSpPr>
-          <p:cNvPr id="9" name="TextBox 8"/>
-          <p:cNvSpPr txBox="1"/>
-          <p:nvPr/>
-        </p:nvSpPr>
-        <p:spPr>
-          <a:xfrm>
-            <a:off x="777240" y="1463039"/>
-            <a:ext cx="6629400" cy="320040"/>
-          </a:xfrm>
-          <a:prstGeom prst="rect">
-            <a:avLst/>
-          </a:prstGeom>
-          <a:noFill/>
-        </p:spPr>
-        <p:txBody>
-          <a:bodyPr wrap="square" lIns="0" rIns="0" tIns="0" bIns="0" anchor="t"/>
-          <a:lstStyle/>
-          <a:p>
-            <a:pPr algn="l"/>
-            <a:r>
-              <a:rPr sz="1400" b="1" i="0">
-                <a:solidFill>
-                  <a:srgbClr val="0B4F9C"/>
-                </a:solidFill>
-                <a:latin typeface="Calibri"/>
-              </a:rPr>
-              <a:t>Step by step</a:t>
-            </a:r>
-          </a:p>
-        </p:txBody>
-      </p:sp>
-      <p:sp>
-        <p:nvSpPr>
-          <p:cNvPr id="10" name="Oval 9"/>
-          <p:cNvSpPr/>
-          <p:nvPr/>
-        </p:nvSpPr>
-        <p:spPr>
-          <a:xfrm>
-            <a:off x="868680" y="1965960"/>
-            <a:ext cx="384048" cy="384048"/>
-          </a:xfrm>
-          <a:prstGeom prst="ellipse">
-            <a:avLst/>
-          </a:prstGeom>
-          <a:solidFill>
-            <a:srgbClr val="1E88E5"/>
-          </a:solidFill>
-          <a:ln>
-            <a:noFill/>
+      <p:pic>
+        <p:nvPicPr>
+          <p:cNvPr id="9" name="Picture 8" descr="image.jpg"/>
+          <p:cNvPicPr>
+            <a:picLocks noChangeAspect="1"/>
+          </p:cNvPicPr>
+          <p:nvPr/>
+        </p:nvPicPr>
+        <p:blipFill>
+          <a:blip r:embed="rId3"/>
+          <a:stretch>
+            <a:fillRect/>
+          </a:stretch>
+        </p:blipFill>
+        <p:spPr>
+          <a:xfrm>
+            <a:off x="457200" y="1280160"/>
+            <a:ext cx="7242048" cy="4526280"/>
+          </a:xfrm>
+          <a:prstGeom prst="rect">
+            <a:avLst/>
+          </a:prstGeom>
+          <a:ln w="6350">
+            <a:solidFill>
+              <a:srgbClr val="D5DEEA"/>
+            </a:solidFill>
           </a:ln>
-          <a:effectLst/>
-        </p:spPr>
-        <p:style>
-          <a:lnRef idx="1">
-            <a:schemeClr val="accent1"/>
-          </a:lnRef>
-          <a:fillRef idx="3">
-            <a:schemeClr val="accent1"/>
-          </a:fillRef>
-          <a:effectRef idx="2">
-            <a:schemeClr val="accent1"/>
-          </a:effectRef>
-          <a:fontRef idx="minor">
-            <a:schemeClr val="lt1"/>
-          </a:fontRef>
-        </p:style>
-        <p:txBody>
-          <a:bodyPr rtlCol="0" anchor="ctr"/>
-          <a:lstStyle/>
-          <a:p>
-            <a:pPr algn="ctr"/>
-          </a:p>
-        </p:txBody>
-      </p:sp>
-      <p:sp>
-        <p:nvSpPr>
-          <p:cNvPr id="11" name="TextBox 10"/>
-          <p:cNvSpPr txBox="1"/>
-          <p:nvPr/>
-        </p:nvSpPr>
-        <p:spPr>
-          <a:xfrm>
-            <a:off x="868680" y="1965960"/>
-            <a:ext cx="384048" cy="384048"/>
-          </a:xfrm>
-          <a:prstGeom prst="rect">
-            <a:avLst/>
-          </a:prstGeom>
-          <a:noFill/>
-        </p:spPr>
-        <p:txBody>
-          <a:bodyPr wrap="square" lIns="0" rIns="0" tIns="0" bIns="0" anchor="ctr"/>
-          <a:lstStyle/>
-          <a:p>
-            <a:pPr algn="ctr"/>
-            <a:r>
-              <a:rPr sz="1300" b="1" i="0">
-                <a:solidFill>
-                  <a:srgbClr val="FFFFFF"/>
-                </a:solidFill>
-                <a:latin typeface="Calibri"/>
-              </a:rPr>
-              <a:t>1</a:t>
-            </a:r>
-          </a:p>
-        </p:txBody>
-      </p:sp>
-      <p:sp>
-        <p:nvSpPr>
-          <p:cNvPr id="12" name="Rectangle 11"/>
-          <p:cNvSpPr/>
-          <p:nvPr/>
-        </p:nvSpPr>
-        <p:spPr>
-          <a:xfrm>
-            <a:off x="1051560" y="2368296"/>
-            <a:ext cx="18288" cy="196595"/>
-          </a:xfrm>
-          <a:prstGeom prst="rect">
-            <a:avLst/>
-          </a:prstGeom>
-          <a:solidFill>
-            <a:srgbClr val="D5DEEA"/>
-          </a:solidFill>
-          <a:ln>
-            <a:noFill/>
-          </a:ln>
-          <a:effectLst/>
-        </p:spPr>
-        <p:style>
-          <a:lnRef idx="1">
-            <a:schemeClr val="accent1"/>
-          </a:lnRef>
-          <a:fillRef idx="3">
-            <a:schemeClr val="accent1"/>
-          </a:fillRef>
-          <a:effectRef idx="2">
-            <a:schemeClr val="accent1"/>
-          </a:effectRef>
-          <a:fontRef idx="minor">
-            <a:schemeClr val="lt1"/>
-          </a:fontRef>
-        </p:style>
-        <p:txBody>
-          <a:bodyPr rtlCol="0" anchor="ctr"/>
-          <a:lstStyle/>
-          <a:p>
-            <a:pPr algn="ctr"/>
-          </a:p>
-        </p:txBody>
-      </p:sp>
-      <p:sp>
-        <p:nvSpPr>
-          <p:cNvPr id="13" name="TextBox 12"/>
-          <p:cNvSpPr txBox="1"/>
-          <p:nvPr/>
-        </p:nvSpPr>
-        <p:spPr>
-          <a:xfrm>
-            <a:off x="1463040" y="1965960"/>
-            <a:ext cx="5897880" cy="384048"/>
-          </a:xfrm>
-          <a:prstGeom prst="rect">
-            <a:avLst/>
-          </a:prstGeom>
-          <a:noFill/>
-        </p:spPr>
-        <p:txBody>
-          <a:bodyPr wrap="square" lIns="0" rIns="0" tIns="0" bIns="0" anchor="ctr"/>
-          <a:lstStyle/>
-          <a:p>
-            <a:pPr algn="l"/>
-            <a:r>
-              <a:rPr sz="1500" b="0" i="0">
-                <a:solidFill>
-                  <a:srgbClr val="1F2937"/>
-                </a:solidFill>
-                <a:latin typeface="Calibri"/>
-              </a:rPr>
-              <a:t>Client accepted (you are notified)</a:t>
-            </a:r>
-          </a:p>
-        </p:txBody>
-      </p:sp>
-      <p:sp>
-        <p:nvSpPr>
-          <p:cNvPr id="14" name="Oval 13"/>
-          <p:cNvSpPr/>
-          <p:nvPr/>
-        </p:nvSpPr>
-        <p:spPr>
-          <a:xfrm>
-            <a:off x="868680" y="2583179"/>
-            <a:ext cx="384048" cy="384048"/>
-          </a:xfrm>
-          <a:prstGeom prst="ellipse">
-            <a:avLst/>
-          </a:prstGeom>
-          <a:solidFill>
-            <a:srgbClr val="1E88E5"/>
-          </a:solidFill>
-          <a:ln>
-            <a:noFill/>
-          </a:ln>
-          <a:effectLst/>
-        </p:spPr>
-        <p:style>
-          <a:lnRef idx="1">
-            <a:schemeClr val="accent1"/>
-          </a:lnRef>
-          <a:fillRef idx="3">
-            <a:schemeClr val="accent1"/>
-          </a:fillRef>
-          <a:effectRef idx="2">
-            <a:schemeClr val="accent1"/>
-          </a:effectRef>
-          <a:fontRef idx="minor">
-            <a:schemeClr val="lt1"/>
-          </a:fontRef>
-        </p:style>
-        <p:txBody>
-          <a:bodyPr rtlCol="0" anchor="ctr"/>
-          <a:lstStyle/>
-          <a:p>
-            <a:pPr algn="ctr"/>
-          </a:p>
-        </p:txBody>
-      </p:sp>
-      <p:sp>
-        <p:nvSpPr>
-          <p:cNvPr id="15" name="TextBox 14"/>
-          <p:cNvSpPr txBox="1"/>
-          <p:nvPr/>
-        </p:nvSpPr>
-        <p:spPr>
-          <a:xfrm>
-            <a:off x="868680" y="2583179"/>
-            <a:ext cx="384048" cy="384048"/>
-          </a:xfrm>
-          <a:prstGeom prst="rect">
-            <a:avLst/>
-          </a:prstGeom>
-          <a:noFill/>
-        </p:spPr>
-        <p:txBody>
-          <a:bodyPr wrap="square" lIns="0" rIns="0" tIns="0" bIns="0" anchor="ctr"/>
-          <a:lstStyle/>
-          <a:p>
-            <a:pPr algn="ctr"/>
-            <a:r>
-              <a:rPr sz="1300" b="1" i="0">
-                <a:solidFill>
-                  <a:srgbClr val="FFFFFF"/>
-                </a:solidFill>
-                <a:latin typeface="Calibri"/>
-              </a:rPr>
-              <a:t>2</a:t>
-            </a:r>
-          </a:p>
-        </p:txBody>
-      </p:sp>
-      <p:sp>
-        <p:nvSpPr>
-          <p:cNvPr id="16" name="Rectangle 15"/>
-          <p:cNvSpPr/>
-          <p:nvPr/>
-        </p:nvSpPr>
-        <p:spPr>
-          <a:xfrm>
-            <a:off x="1051560" y="2985515"/>
-            <a:ext cx="18288" cy="196595"/>
-          </a:xfrm>
-          <a:prstGeom prst="rect">
-            <a:avLst/>
-          </a:prstGeom>
-          <a:solidFill>
-            <a:srgbClr val="D5DEEA"/>
-          </a:solidFill>
-          <a:ln>
-            <a:noFill/>
-          </a:ln>
-          <a:effectLst/>
-        </p:spPr>
-        <p:style>
-          <a:lnRef idx="1">
-            <a:schemeClr val="accent1"/>
-          </a:lnRef>
-          <a:fillRef idx="3">
-            <a:schemeClr val="accent1"/>
-          </a:fillRef>
-          <a:effectRef idx="2">
-            <a:schemeClr val="accent1"/>
-          </a:effectRef>
-          <a:fontRef idx="minor">
-            <a:schemeClr val="lt1"/>
-          </a:fontRef>
-        </p:style>
-        <p:txBody>
-          <a:bodyPr rtlCol="0" anchor="ctr"/>
-          <a:lstStyle/>
-          <a:p>
-            <a:pPr algn="ctr"/>
-          </a:p>
-        </p:txBody>
-      </p:sp>
-      <p:sp>
-        <p:nvSpPr>
-          <p:cNvPr id="17" name="TextBox 16"/>
-          <p:cNvSpPr txBox="1"/>
-          <p:nvPr/>
-        </p:nvSpPr>
-        <p:spPr>
-          <a:xfrm>
-            <a:off x="1463040" y="2583179"/>
-            <a:ext cx="5897880" cy="384048"/>
-          </a:xfrm>
-          <a:prstGeom prst="rect">
-            <a:avLst/>
-          </a:prstGeom>
-          <a:noFill/>
-        </p:spPr>
-        <p:txBody>
-          <a:bodyPr wrap="square" lIns="0" rIns="0" tIns="0" bIns="0" anchor="ctr"/>
-          <a:lstStyle/>
-          <a:p>
-            <a:pPr algn="l"/>
-            <a:r>
-              <a:rPr sz="1500" b="0" i="0">
-                <a:solidFill>
-                  <a:srgbClr val="1F2937"/>
-                </a:solidFill>
-                <a:latin typeface="Calibri"/>
-              </a:rPr>
-              <a:t>Customer information and ID</a:t>
-            </a:r>
-          </a:p>
-        </p:txBody>
-      </p:sp>
-      <p:sp>
-        <p:nvSpPr>
-          <p:cNvPr id="18" name="Oval 17"/>
-          <p:cNvSpPr/>
-          <p:nvPr/>
-        </p:nvSpPr>
-        <p:spPr>
-          <a:xfrm>
-            <a:off x="868680" y="3200400"/>
-            <a:ext cx="384048" cy="384048"/>
-          </a:xfrm>
-          <a:prstGeom prst="ellipse">
-            <a:avLst/>
-          </a:prstGeom>
-          <a:solidFill>
-            <a:srgbClr val="1E88E5"/>
-          </a:solidFill>
-          <a:ln>
-            <a:noFill/>
-          </a:ln>
-          <a:effectLst/>
-        </p:spPr>
-        <p:style>
-          <a:lnRef idx="1">
-            <a:schemeClr val="accent1"/>
-          </a:lnRef>
-          <a:fillRef idx="3">
-            <a:schemeClr val="accent1"/>
-          </a:fillRef>
-          <a:effectRef idx="2">
-            <a:schemeClr val="accent1"/>
-          </a:effectRef>
-          <a:fontRef idx="minor">
-            <a:schemeClr val="lt1"/>
-          </a:fontRef>
-        </p:style>
-        <p:txBody>
-          <a:bodyPr rtlCol="0" anchor="ctr"/>
-          <a:lstStyle/>
-          <a:p>
-            <a:pPr algn="ctr"/>
-          </a:p>
-        </p:txBody>
-      </p:sp>
-      <p:sp>
-        <p:nvSpPr>
-          <p:cNvPr id="19" name="TextBox 18"/>
-          <p:cNvSpPr txBox="1"/>
-          <p:nvPr/>
-        </p:nvSpPr>
-        <p:spPr>
-          <a:xfrm>
-            <a:off x="868680" y="3200400"/>
-            <a:ext cx="384048" cy="384048"/>
-          </a:xfrm>
-          <a:prstGeom prst="rect">
-            <a:avLst/>
-          </a:prstGeom>
-          <a:noFill/>
-        </p:spPr>
-        <p:txBody>
-          <a:bodyPr wrap="square" lIns="0" rIns="0" tIns="0" bIns="0" anchor="ctr"/>
-          <a:lstStyle/>
-          <a:p>
-            <a:pPr algn="ctr"/>
-            <a:r>
-              <a:rPr sz="1300" b="1" i="0">
-                <a:solidFill>
-                  <a:srgbClr val="FFFFFF"/>
-                </a:solidFill>
-                <a:latin typeface="Calibri"/>
-              </a:rPr>
-              <a:t>3</a:t>
-            </a:r>
-          </a:p>
-        </p:txBody>
-      </p:sp>
-      <p:sp>
-        <p:nvSpPr>
-          <p:cNvPr id="20" name="Rectangle 19"/>
-          <p:cNvSpPr/>
-          <p:nvPr/>
-        </p:nvSpPr>
-        <p:spPr>
-          <a:xfrm>
-            <a:off x="1051560" y="3602736"/>
-            <a:ext cx="18288" cy="196595"/>
-          </a:xfrm>
-          <a:prstGeom prst="rect">
-            <a:avLst/>
-          </a:prstGeom>
-          <a:solidFill>
-            <a:srgbClr val="D5DEEA"/>
-          </a:solidFill>
-          <a:ln>
-            <a:noFill/>
-          </a:ln>
-          <a:effectLst/>
-        </p:spPr>
-        <p:style>
-          <a:lnRef idx="1">
-            <a:schemeClr val="accent1"/>
-          </a:lnRef>
-          <a:fillRef idx="3">
-            <a:schemeClr val="accent1"/>
-          </a:fillRef>
-          <a:effectRef idx="2">
-            <a:schemeClr val="accent1"/>
-          </a:effectRef>
-          <a:fontRef idx="minor">
-            <a:schemeClr val="lt1"/>
-          </a:fontRef>
-        </p:style>
-        <p:txBody>
-          <a:bodyPr rtlCol="0" anchor="ctr"/>
-          <a:lstStyle/>
-          <a:p>
-            <a:pPr algn="ctr"/>
-          </a:p>
-        </p:txBody>
-      </p:sp>
-      <p:sp>
-        <p:nvSpPr>
-          <p:cNvPr id="21" name="TextBox 20"/>
-          <p:cNvSpPr txBox="1"/>
-          <p:nvPr/>
-        </p:nvSpPr>
-        <p:spPr>
-          <a:xfrm>
-            <a:off x="1463040" y="3200400"/>
-            <a:ext cx="5897880" cy="384048"/>
-          </a:xfrm>
-          <a:prstGeom prst="rect">
-            <a:avLst/>
-          </a:prstGeom>
-          <a:noFill/>
-        </p:spPr>
-        <p:txBody>
-          <a:bodyPr wrap="square" lIns="0" rIns="0" tIns="0" bIns="0" anchor="ctr"/>
-          <a:lstStyle/>
-          <a:p>
-            <a:pPr algn="l"/>
-            <a:r>
-              <a:rPr sz="1500" b="0" i="0">
-                <a:solidFill>
-                  <a:srgbClr val="1F2937"/>
-                </a:solidFill>
-                <a:latin typeface="Calibri"/>
-              </a:rPr>
-              <a:t>Vehicle details and photos</a:t>
-            </a:r>
-          </a:p>
-        </p:txBody>
-      </p:sp>
-      <p:sp>
-        <p:nvSpPr>
-          <p:cNvPr id="22" name="Oval 21"/>
-          <p:cNvSpPr/>
-          <p:nvPr/>
-        </p:nvSpPr>
-        <p:spPr>
-          <a:xfrm>
-            <a:off x="868680" y="3817620"/>
-            <a:ext cx="384048" cy="384048"/>
-          </a:xfrm>
-          <a:prstGeom prst="ellipse">
-            <a:avLst/>
-          </a:prstGeom>
-          <a:solidFill>
-            <a:srgbClr val="1E88E5"/>
-          </a:solidFill>
-          <a:ln>
-            <a:noFill/>
-          </a:ln>
-          <a:effectLst/>
-        </p:spPr>
-        <p:style>
-          <a:lnRef idx="1">
-            <a:schemeClr val="accent1"/>
-          </a:lnRef>
-          <a:fillRef idx="3">
-            <a:schemeClr val="accent1"/>
-          </a:fillRef>
-          <a:effectRef idx="2">
-            <a:schemeClr val="accent1"/>
-          </a:effectRef>
-          <a:fontRef idx="minor">
-            <a:schemeClr val="lt1"/>
-          </a:fontRef>
-        </p:style>
-        <p:txBody>
-          <a:bodyPr rtlCol="0" anchor="ctr"/>
-          <a:lstStyle/>
-          <a:p>
-            <a:pPr algn="ctr"/>
-          </a:p>
-        </p:txBody>
-      </p:sp>
-      <p:sp>
-        <p:nvSpPr>
-          <p:cNvPr id="23" name="TextBox 22"/>
-          <p:cNvSpPr txBox="1"/>
-          <p:nvPr/>
-        </p:nvSpPr>
-        <p:spPr>
-          <a:xfrm>
-            <a:off x="868680" y="3817620"/>
-            <a:ext cx="384048" cy="384048"/>
-          </a:xfrm>
-          <a:prstGeom prst="rect">
-            <a:avLst/>
-          </a:prstGeom>
-          <a:noFill/>
-        </p:spPr>
-        <p:txBody>
-          <a:bodyPr wrap="square" lIns="0" rIns="0" tIns="0" bIns="0" anchor="ctr"/>
-          <a:lstStyle/>
-          <a:p>
-            <a:pPr algn="ctr"/>
-            <a:r>
-              <a:rPr sz="1300" b="1" i="0">
-                <a:solidFill>
-                  <a:srgbClr val="FFFFFF"/>
-                </a:solidFill>
-                <a:latin typeface="Calibri"/>
-              </a:rPr>
-              <a:t>4</a:t>
-            </a:r>
-          </a:p>
-        </p:txBody>
-      </p:sp>
-      <p:sp>
-        <p:nvSpPr>
-          <p:cNvPr id="24" name="Rectangle 23"/>
-          <p:cNvSpPr/>
-          <p:nvPr/>
-        </p:nvSpPr>
-        <p:spPr>
-          <a:xfrm>
-            <a:off x="1051560" y="4219956"/>
-            <a:ext cx="18288" cy="196595"/>
-          </a:xfrm>
-          <a:prstGeom prst="rect">
-            <a:avLst/>
-          </a:prstGeom>
-          <a:solidFill>
-            <a:srgbClr val="D5DEEA"/>
-          </a:solidFill>
-          <a:ln>
-            <a:noFill/>
-          </a:ln>
-          <a:effectLst/>
-        </p:spPr>
-        <p:style>
-          <a:lnRef idx="1">
-            <a:schemeClr val="accent1"/>
-          </a:lnRef>
-          <a:fillRef idx="3">
-            <a:schemeClr val="accent1"/>
-          </a:fillRef>
-          <a:effectRef idx="2">
-            <a:schemeClr val="accent1"/>
-          </a:effectRef>
-          <a:fontRef idx="minor">
-            <a:schemeClr val="lt1"/>
-          </a:fontRef>
-        </p:style>
-        <p:txBody>
-          <a:bodyPr rtlCol="0" anchor="ctr"/>
-          <a:lstStyle/>
-          <a:p>
-            <a:pPr algn="ctr"/>
-          </a:p>
-        </p:txBody>
-      </p:sp>
-      <p:sp>
-        <p:nvSpPr>
-          <p:cNvPr id="25" name="TextBox 24"/>
-          <p:cNvSpPr txBox="1"/>
-          <p:nvPr/>
-        </p:nvSpPr>
-        <p:spPr>
-          <a:xfrm>
-            <a:off x="1463040" y="3817620"/>
-            <a:ext cx="5897880" cy="384048"/>
-          </a:xfrm>
-          <a:prstGeom prst="rect">
-            <a:avLst/>
-          </a:prstGeom>
-          <a:noFill/>
-        </p:spPr>
-        <p:txBody>
-          <a:bodyPr wrap="square" lIns="0" rIns="0" tIns="0" bIns="0" anchor="ctr"/>
-          <a:lstStyle/>
-          <a:p>
-            <a:pPr algn="l"/>
-            <a:r>
-              <a:rPr sz="1500" b="0" i="0">
-                <a:solidFill>
-                  <a:srgbClr val="1F2937"/>
-                </a:solidFill>
-                <a:latin typeface="Calibri"/>
-              </a:rPr>
-              <a:t>Upload policy documents</a:t>
-            </a:r>
-          </a:p>
-        </p:txBody>
-      </p:sp>
-      <p:sp>
-        <p:nvSpPr>
-          <p:cNvPr id="26" name="Oval 25"/>
-          <p:cNvSpPr/>
-          <p:nvPr/>
-        </p:nvSpPr>
-        <p:spPr>
-          <a:xfrm>
-            <a:off x="868680" y="4434840"/>
-            <a:ext cx="384048" cy="384048"/>
-          </a:xfrm>
-          <a:prstGeom prst="ellipse">
-            <a:avLst/>
-          </a:prstGeom>
-          <a:solidFill>
-            <a:srgbClr val="1E88E5"/>
-          </a:solidFill>
-          <a:ln>
-            <a:noFill/>
-          </a:ln>
-          <a:effectLst/>
-        </p:spPr>
-        <p:style>
-          <a:lnRef idx="1">
-            <a:schemeClr val="accent1"/>
-          </a:lnRef>
-          <a:fillRef idx="3">
-            <a:schemeClr val="accent1"/>
-          </a:fillRef>
-          <a:effectRef idx="2">
-            <a:schemeClr val="accent1"/>
-          </a:effectRef>
-          <a:fontRef idx="minor">
-            <a:schemeClr val="lt1"/>
-          </a:fontRef>
-        </p:style>
-        <p:txBody>
-          <a:bodyPr rtlCol="0" anchor="ctr"/>
-          <a:lstStyle/>
-          <a:p>
-            <a:pPr algn="ctr"/>
-          </a:p>
-        </p:txBody>
-      </p:sp>
-      <p:sp>
-        <p:nvSpPr>
-          <p:cNvPr id="27" name="TextBox 26"/>
-          <p:cNvSpPr txBox="1"/>
-          <p:nvPr/>
-        </p:nvSpPr>
-        <p:spPr>
-          <a:xfrm>
-            <a:off x="868680" y="4434840"/>
-            <a:ext cx="384048" cy="384048"/>
-          </a:xfrm>
-          <a:prstGeom prst="rect">
-            <a:avLst/>
-          </a:prstGeom>
-          <a:noFill/>
-        </p:spPr>
-        <p:txBody>
-          <a:bodyPr wrap="square" lIns="0" rIns="0" tIns="0" bIns="0" anchor="ctr"/>
-          <a:lstStyle/>
-          <a:p>
-            <a:pPr algn="ctr"/>
-            <a:r>
-              <a:rPr sz="1300" b="1" i="0">
-                <a:solidFill>
-                  <a:srgbClr val="FFFFFF"/>
-                </a:solidFill>
-                <a:latin typeface="Calibri"/>
-              </a:rPr>
-              <a:t>5</a:t>
-            </a:r>
-          </a:p>
-        </p:txBody>
-      </p:sp>
-      <p:sp>
-        <p:nvSpPr>
-          <p:cNvPr id="28" name="Rectangle 27"/>
-          <p:cNvSpPr/>
-          <p:nvPr/>
-        </p:nvSpPr>
-        <p:spPr>
-          <a:xfrm>
-            <a:off x="1051560" y="4837176"/>
-            <a:ext cx="18288" cy="196595"/>
-          </a:xfrm>
-          <a:prstGeom prst="rect">
-            <a:avLst/>
-          </a:prstGeom>
-          <a:solidFill>
-            <a:srgbClr val="D5DEEA"/>
-          </a:solidFill>
-          <a:ln>
-            <a:noFill/>
-          </a:ln>
-          <a:effectLst/>
-        </p:spPr>
-        <p:style>
-          <a:lnRef idx="1">
-            <a:schemeClr val="accent1"/>
-          </a:lnRef>
-          <a:fillRef idx="3">
-            <a:schemeClr val="accent1"/>
-          </a:fillRef>
-          <a:effectRef idx="2">
-            <a:schemeClr val="accent1"/>
-          </a:effectRef>
-          <a:fontRef idx="minor">
-            <a:schemeClr val="lt1"/>
-          </a:fontRef>
-        </p:style>
-        <p:txBody>
-          <a:bodyPr rtlCol="0" anchor="ctr"/>
-          <a:lstStyle/>
-          <a:p>
-            <a:pPr algn="ctr"/>
-          </a:p>
-        </p:txBody>
-      </p:sp>
-      <p:sp>
-        <p:nvSpPr>
-          <p:cNvPr id="29" name="TextBox 28"/>
-          <p:cNvSpPr txBox="1"/>
-          <p:nvPr/>
-        </p:nvSpPr>
-        <p:spPr>
-          <a:xfrm>
-            <a:off x="1463040" y="4434840"/>
-            <a:ext cx="5897880" cy="384048"/>
-          </a:xfrm>
-          <a:prstGeom prst="rect">
-            <a:avLst/>
-          </a:prstGeom>
-          <a:noFill/>
-        </p:spPr>
-        <p:txBody>
-          <a:bodyPr wrap="square" lIns="0" rIns="0" tIns="0" bIns="0" anchor="ctr"/>
-          <a:lstStyle/>
-          <a:p>
-            <a:pPr algn="l"/>
-            <a:r>
-              <a:rPr sz="1500" b="0" i="0">
-                <a:solidFill>
-                  <a:srgbClr val="1F2937"/>
-                </a:solidFill>
-                <a:latin typeface="Calibri"/>
-              </a:rPr>
-              <a:t>Payment confirmation</a:t>
-            </a:r>
-          </a:p>
-        </p:txBody>
-      </p:sp>
-      <p:sp>
-        <p:nvSpPr>
-          <p:cNvPr id="30" name="Oval 29"/>
-          <p:cNvSpPr/>
-          <p:nvPr/>
-        </p:nvSpPr>
-        <p:spPr>
-          <a:xfrm>
-            <a:off x="868680" y="5052059"/>
-            <a:ext cx="384048" cy="384048"/>
-          </a:xfrm>
-          <a:prstGeom prst="ellipse">
-            <a:avLst/>
-          </a:prstGeom>
-          <a:solidFill>
-            <a:srgbClr val="43A047"/>
-          </a:solidFill>
-          <a:ln>
-            <a:noFill/>
-          </a:ln>
-          <a:effectLst/>
-        </p:spPr>
-        <p:style>
-          <a:lnRef idx="1">
-            <a:schemeClr val="accent1"/>
-          </a:lnRef>
-          <a:fillRef idx="3">
-            <a:schemeClr val="accent1"/>
-          </a:fillRef>
-          <a:effectRef idx="2">
-            <a:schemeClr val="accent1"/>
-          </a:effectRef>
-          <a:fontRef idx="minor">
-            <a:schemeClr val="lt1"/>
-          </a:fontRef>
-        </p:style>
-        <p:txBody>
-          <a:bodyPr rtlCol="0" anchor="ctr"/>
-          <a:lstStyle/>
-          <a:p>
-            <a:pPr algn="ctr"/>
-          </a:p>
-        </p:txBody>
-      </p:sp>
-      <p:sp>
-        <p:nvSpPr>
-          <p:cNvPr id="31" name="TextBox 30"/>
-          <p:cNvSpPr txBox="1"/>
-          <p:nvPr/>
-        </p:nvSpPr>
-        <p:spPr>
-          <a:xfrm>
-            <a:off x="868680" y="5052059"/>
-            <a:ext cx="384048" cy="384048"/>
-          </a:xfrm>
-          <a:prstGeom prst="rect">
-            <a:avLst/>
-          </a:prstGeom>
-          <a:noFill/>
-        </p:spPr>
-        <p:txBody>
-          <a:bodyPr wrap="square" lIns="0" rIns="0" tIns="0" bIns="0" anchor="ctr"/>
-          <a:lstStyle/>
-          <a:p>
-            <a:pPr algn="ctr"/>
-            <a:r>
-              <a:rPr sz="1300" b="1" i="0">
-                <a:solidFill>
-                  <a:srgbClr val="FFFFFF"/>
-                </a:solidFill>
-                <a:latin typeface="Calibri"/>
-              </a:rPr>
-              <a:t>6</a:t>
-            </a:r>
-          </a:p>
-        </p:txBody>
-      </p:sp>
-      <p:sp>
-        <p:nvSpPr>
-          <p:cNvPr id="32" name="TextBox 31"/>
-          <p:cNvSpPr txBox="1"/>
-          <p:nvPr/>
-        </p:nvSpPr>
-        <p:spPr>
-          <a:xfrm>
-            <a:off x="1463040" y="5052059"/>
-            <a:ext cx="5897880" cy="384048"/>
-          </a:xfrm>
-          <a:prstGeom prst="rect">
-            <a:avLst/>
-          </a:prstGeom>
-          <a:noFill/>
-        </p:spPr>
-        <p:txBody>
-          <a:bodyPr wrap="square" lIns="0" rIns="0" tIns="0" bIns="0" anchor="ctr"/>
-          <a:lstStyle/>
-          <a:p>
-            <a:pPr algn="l"/>
-            <a:r>
-              <a:rPr sz="1500" b="0" i="0">
-                <a:solidFill>
-                  <a:srgbClr val="1F2937"/>
-                </a:solidFill>
-                <a:latin typeface="Calibri"/>
-              </a:rPr>
-              <a:t>Policy issued</a:t>
-            </a:r>
-          </a:p>
-        </p:txBody>
-      </p:sp>
-      <p:sp>
-        <p:nvSpPr>
-          <p:cNvPr id="33" name="TextBox 32"/>
+        </p:spPr>
+      </p:pic>
+      <p:sp>
+        <p:nvSpPr>
+          <p:cNvPr id="10" name="TextBox 9"/>
           <p:cNvSpPr txBox="1"/>
           <p:nvPr/>
         </p:nvSpPr>
@@ -15765,14 +13930,14 @@
                 </a:solidFill>
                 <a:latin typeface="Calibri"/>
               </a:rPr>
-              <a:t>Conversion steps (POL-2026-00001)</a:t>
-            </a:r>
-          </a:p>
-        </p:txBody>
-      </p:sp>
-      <p:sp>
-        <p:nvSpPr>
-          <p:cNvPr id="34" name="Rounded Rectangle 33"/>
+              <a:t>Live screen — Coverage review with the billing mode before Send to Insurance Company — signed in as ramon.agent</a:t>
+            </a:r>
+          </a:p>
+        </p:txBody>
+      </p:sp>
+      <p:sp>
+        <p:nvSpPr>
+          <p:cNvPr id="11" name="Rounded Rectangle 10"/>
           <p:cNvSpPr/>
           <p:nvPr/>
         </p:nvSpPr>
@@ -15820,7 +13985,7 @@
       </p:sp>
       <p:sp>
         <p:nvSpPr>
-          <p:cNvPr id="35" name="TextBox 34"/>
+          <p:cNvPr id="12" name="TextBox 11"/>
           <p:cNvSpPr txBox="1"/>
           <p:nvPr/>
         </p:nvSpPr>
@@ -15846,14 +14011,14 @@
                 </a:solidFill>
                 <a:latin typeface="Calibri"/>
               </a:rPr>
-              <a:t>Operations &gt; Quotation &gt; Convert</a:t>
-            </a:r>
-          </a:p>
-        </p:txBody>
-      </p:sp>
-      <p:sp>
-        <p:nvSpPr>
-          <p:cNvPr id="36" name="TextBox 35"/>
+              <a:t>Quotation &gt; Proceed to Policy</a:t>
+            </a:r>
+          </a:p>
+        </p:txBody>
+      </p:sp>
+      <p:sp>
+        <p:nvSpPr>
+          <p:cNvPr id="13" name="TextBox 12"/>
           <p:cNvSpPr txBox="1"/>
           <p:nvPr/>
         </p:nvSpPr>
@@ -15888,7 +14053,7 @@
                 </a:solidFill>
                 <a:latin typeface="Calibri"/>
               </a:rPr>
-              <a:t>Documents:  </a:t>
+              <a:t>KYC:  </a:t>
             </a:r>
             <a:r>
               <a:rPr sz="1500">
@@ -15897,7 +14062,7 @@
                 </a:solidFill>
                 <a:latin typeface="Calibri"/>
               </a:rPr>
-              <a:t>ID, vehicle photos and the insurer policy are stored with the policy.</a:t>
+              <a:t>ID type, number and image, chassis, motor and plate or MV file number are required.</a:t>
             </a:r>
           </a:p>
           <a:p>
@@ -15918,7 +14083,7 @@
                 </a:solidFill>
                 <a:latin typeface="Calibri"/>
               </a:rPr>
-              <a:t>Downstream:  </a:t>
+              <a:t>Billing:  </a:t>
             </a:r>
             <a:r>
               <a:rPr sz="1500">
@@ -15927,7 +14092,7 @@
                 </a:solidFill>
                 <a:latin typeface="Calibri"/>
               </a:rPr>
-              <a:t>bill INV-2026-00001, booking journal, collection item, commission 4,200.75 accrued.</a:t>
+              <a:t>broker billed (default) or direct bill, chosen on Send to Insurance Company.</a:t>
             </a:r>
           </a:p>
           <a:p>
@@ -15948,7 +14113,7 @@
                 </a:solidFill>
                 <a:latin typeface="Calibri"/>
               </a:rPr>
-              <a:t>Dashboard:  </a:t>
+              <a:t>Downstream:  </a:t>
             </a:r>
             <a:r>
               <a:rPr sz="1500">
@@ -15957,7 +14122,7 @@
                 </a:solidFill>
                 <a:latin typeface="Calibri"/>
               </a:rPr>
-              <a:t>+1 policy and +35,076.27 premium straight away.</a:t>
+              <a:t>bill INV-, booking journal, collection item and commission accrued (e.g. 4,200.75 on POL-2026-00001).</a:t>
             </a:r>
           </a:p>
           <a:p>
@@ -15978,7 +14143,7 @@
                 </a:solidFill>
                 <a:latin typeface="Calibri"/>
               </a:rPr>
-              <a:t>Check:  </a:t>
+              <a:t>Payment:  </a:t>
             </a:r>
             <a:r>
               <a:rPr sz="1500">
@@ -15987,7 +14152,7 @@
                 </a:solidFill>
                 <a:latin typeface="Calibri"/>
               </a:rPr>
-              <a:t>complete KYC and vehicle identifiers before Next.</a:t>
+              <a:t>record how the client paid; Finance verifies it and posts the receipt.</a:t>
             </a:r>
           </a:p>
         </p:txBody>
@@ -16513,7 +14678,7 @@
                 </a:solidFill>
                 <a:latin typeface="Calibri"/>
               </a:rPr>
-              <a:t>start the renewal quote from the policy row.</a:t>
+              <a:t>row menu &gt; Renewal starts the renewal quote, linked to the expiring policy.</a:t>
             </a:r>
           </a:p>
           <a:p>
@@ -16543,7 +14708,7 @@
                 </a:solidFill>
                 <a:latin typeface="Calibri"/>
               </a:rPr>
-              <a:t>empty tiles mean none of your policies are due.</a:t>
+              <a:t>only your own policies; the renewals workspace is run by Sales and Underwriting.</a:t>
             </a:r>
           </a:p>
         </p:txBody>
@@ -17771,7 +15936,7 @@
                 </a:solidFill>
                 <a:latin typeface="Calibri"/>
               </a:rPr>
-              <a:t>the reason is shown, e.g. “outside the policy period 2026-09-28 to 2027-09-28”.</a:t>
+              <a:t>the reason is shown, e.g. “Date of loss … is outside the policy period”; unpaid premium also blocks it.</a:t>
             </a:r>
           </a:p>
           <a:p>

</xml_diff>